<commit_message>
Fix duplicate source link on 홈플러스 메리츠 이사회 2000억 item
It pointed at the same URL as the preceding MBK-rally item instead of
its own article -- I'd reused that URL as a placeholder (labeled
"종합보도") instead of finding the actual source when the report was
first generated. Now points to the real newspim article on the Meritz
board's DIP funding decision. Comment box content saved by the user
via the save button was preserved untouched.
</commit_message>
<xml_diff>
--- a/reports/2026-07-13_2026-07-19.pptx
+++ b/reports/2026-07-13_2026-07-19.pptx
@@ -4284,7 +4284,7 @@
                 <a:latin typeface="Malgun Gothic"/>
                 <a:ea typeface="Malgun Gothic"/>
                 <a:cs typeface="Malgun Gothic"/>
-                <a:hlinkClick r:id="rId4"/>
+                <a:hlinkClick r:id="rId5"/>
               </a:rPr>
               <a:t>홈플러스, 메리츠 이사회 극적 의결로 2000억 확보</a:t>
             </a:r>
@@ -4356,7 +4356,7 @@
                 <a:ea typeface="Malgun Gothic"/>
                 <a:cs typeface="Malgun Gothic"/>
               </a:rPr>
-              <a:t>종합보도 · 2026.07.16</a:t>
+              <a:t>뉴스핌 · 2026.07.16</a:t>
             </a:r>
           </a:p>
         </p:txBody>
@@ -4631,7 +4631,7 @@
                 <a:latin typeface="Malgun Gothic"/>
                 <a:ea typeface="Malgun Gothic"/>
                 <a:cs typeface="Malgun Gothic"/>
-                <a:hlinkClick r:id="rId5"/>
+                <a:hlinkClick r:id="rId6"/>
               </a:rPr>
               <a:t>울산지노위, 현대차 사내하청 '사용자성' 첫 인정</a:t>
             </a:r>
@@ -4838,7 +4838,7 @@
                 <a:latin typeface="Malgun Gothic"/>
                 <a:ea typeface="Malgun Gothic"/>
                 <a:cs typeface="Malgun Gothic"/>
-                <a:hlinkClick r:id="rId6"/>
+                <a:hlinkClick r:id="rId7"/>
               </a:rPr>
               <a:t>민주노총, 노란봉투법 시행 후 첫 총파업 돌입</a:t>
             </a:r>
@@ -4988,7 +4988,7 @@
                 <a:latin typeface="Malgun Gothic"/>
                 <a:ea typeface="Malgun Gothic"/>
                 <a:cs typeface="Malgun Gothic"/>
-                <a:hlinkClick r:id="rId7"/>
+                <a:hlinkClick r:id="rId8"/>
               </a:rPr>
               <a:t>현대차 노조, 부분파업 지속…임단협 장기전</a:t>
             </a:r>
@@ -5138,7 +5138,7 @@
                 <a:latin typeface="Malgun Gothic"/>
                 <a:ea typeface="Malgun Gothic"/>
                 <a:cs typeface="Malgun Gothic"/>
-                <a:hlinkClick r:id="rId8"/>
+                <a:hlinkClick r:id="rId9"/>
               </a:rPr>
               <a:t>포스코, 58년 무분규 기록 깨지나…쟁의행위 가결</a:t>
             </a:r>
@@ -5288,7 +5288,7 @@
                 <a:latin typeface="Malgun Gothic"/>
                 <a:ea typeface="Malgun Gothic"/>
                 <a:cs typeface="Malgun Gothic"/>
-                <a:hlinkClick r:id="rId9"/>
+                <a:hlinkClick r:id="rId10"/>
               </a:rPr>
               <a:t>금융노조, 주4.5일제 두고 하투 격화</a:t>
             </a:r>

</xml_diff>